<commit_message>
Activité 98 · les 19 images, le module régénéré avec son repère, les séances reprises
</commit_message>
<xml_diff>
--- a/assets/powerpoints/module-n1-classe/A1-voici-ta-place.pptx
+++ b/assets/powerpoints/module-n1-classe/A1-voici-ta-place.pptx
@@ -6964,12 +6964,12 @@
         </p:nvSpPr>
         <p:spPr>
           <a:xfrm>
-            <a:off x="566928" y="1856232"/>
-            <a:ext cx="11057839" cy="703579"/>
+            <a:off x="7424927" y="1719072"/>
+            <a:ext cx="4199839" cy="4361688"/>
           </a:xfrm>
           <a:prstGeom prst="roundRect">
             <a:avLst>
-              <a:gd name="adj" fmla="val 20794"/>
+              <a:gd name="adj" fmla="val 3483"/>
             </a:avLst>
           </a:prstGeom>
           <a:solidFill>
@@ -7002,97 +7002,40 @@
           <a:p/>
         </p:txBody>
       </p:sp>
-      <p:sp>
-        <p:nvSpPr>
-          <p:cNvPr id="8" name="Rectangle 7"/>
+      <p:pic>
+        <p:nvPicPr>
+          <p:cNvPr id="8" name="Picture 7" descr="salle-vide.jpg"/>
+          <p:cNvPicPr>
+            <a:picLocks noChangeAspect="1"/>
+          </p:cNvPicPr>
+          <p:nvPr/>
+        </p:nvPicPr>
+        <p:blipFill>
+          <a:blip r:embed="rId2"/>
+          <a:stretch>
+            <a:fillRect/>
+          </a:stretch>
+        </p:blipFill>
+        <p:spPr>
+          <a:xfrm>
+            <a:off x="7644383" y="2638438"/>
+            <a:ext cx="3760927" cy="2522955"/>
+          </a:xfrm>
+          <a:prstGeom prst="rect">
+            <a:avLst/>
+          </a:prstGeom>
+        </p:spPr>
+      </p:pic>
+      <p:sp>
+        <p:nvSpPr>
+          <p:cNvPr id="9" name="Rounded Rectangle 8"/>
           <p:cNvSpPr/>
           <p:nvPr/>
         </p:nvSpPr>
         <p:spPr>
           <a:xfrm>
-            <a:off x="566928" y="1965960"/>
-            <a:ext cx="50292" cy="484123"/>
-          </a:xfrm>
-          <a:prstGeom prst="rect">
-            <a:avLst/>
-          </a:prstGeom>
-          <a:solidFill>
-            <a:srgbClr val="1D6B8F"/>
-          </a:solidFill>
-          <a:ln>
-            <a:noFill/>
-          </a:ln>
-          <a:effectLst/>
-        </p:spPr>
-        <p:style>
-          <a:lnRef idx="1">
-            <a:schemeClr val="accent1"/>
-          </a:lnRef>
-          <a:fillRef idx="3">
-            <a:schemeClr val="accent1"/>
-          </a:fillRef>
-          <a:effectRef idx="2">
-            <a:schemeClr val="accent1"/>
-          </a:effectRef>
-          <a:fontRef idx="minor">
-            <a:schemeClr val="lt1"/>
-          </a:fontRef>
-        </p:style>
-        <p:txBody>
-          <a:bodyPr rtlCol="0" anchor="ctr"/>
-          <a:lstStyle/>
-          <a:p/>
-        </p:txBody>
-      </p:sp>
-      <p:sp>
-        <p:nvSpPr>
-          <p:cNvPr id="9" name="TextBox 8"/>
-          <p:cNvSpPr txBox="1"/>
-          <p:nvPr/>
-        </p:nvSpPr>
-        <p:spPr>
-          <a:xfrm>
-            <a:off x="950976" y="2039112"/>
-            <a:ext cx="10372039" cy="374395"/>
-          </a:xfrm>
-          <a:prstGeom prst="rect">
-            <a:avLst/>
-          </a:prstGeom>
-          <a:noFill/>
-        </p:spPr>
-        <p:txBody>
-          <a:bodyPr wrap="square" lIns="0" rIns="0" tIns="0" bIns="0" anchor="t">
-            <a:spAutoFit/>
-          </a:bodyPr>
-          <a:lstStyle/>
-          <a:p>
-            <a:pPr algn="l">
-              <a:lnSpc>
-                <a:spcPct val="140000"/>
-              </a:lnSpc>
-            </a:pPr>
-            <a:r>
-              <a:rPr sz="1900" b="0" i="0">
-                <a:solidFill>
-                  <a:srgbClr val="3A3D40"/>
-                </a:solidFill>
-                <a:latin typeface="Verdana"/>
-              </a:rPr>
-              <a:t>Où sommes-nous ?</a:t>
-            </a:r>
-          </a:p>
-        </p:txBody>
-      </p:sp>
-      <p:sp>
-        <p:nvSpPr>
-          <p:cNvPr id="10" name="Rounded Rectangle 9"/>
-          <p:cNvSpPr/>
-          <p:nvPr/>
-        </p:nvSpPr>
-        <p:spPr>
-          <a:xfrm>
-            <a:off x="566928" y="2642108"/>
-            <a:ext cx="11057839" cy="703579"/>
+            <a:off x="566928" y="1856232"/>
+            <a:ext cx="6492240" cy="703579"/>
           </a:xfrm>
           <a:prstGeom prst="roundRect">
             <a:avLst>
@@ -7131,13 +7074,13 @@
       </p:sp>
       <p:sp>
         <p:nvSpPr>
-          <p:cNvPr id="11" name="Rectangle 10"/>
+          <p:cNvPr id="10" name="Rectangle 9"/>
           <p:cNvSpPr/>
           <p:nvPr/>
         </p:nvSpPr>
         <p:spPr>
           <a:xfrm>
-            <a:off x="566928" y="2751836"/>
+            <a:off x="566928" y="1965960"/>
             <a:ext cx="50292" cy="484123"/>
           </a:xfrm>
           <a:prstGeom prst="rect">
@@ -7173,14 +7116,14 @@
       </p:sp>
       <p:sp>
         <p:nvSpPr>
-          <p:cNvPr id="12" name="TextBox 11"/>
+          <p:cNvPr id="11" name="TextBox 10"/>
           <p:cNvSpPr txBox="1"/>
           <p:nvPr/>
         </p:nvSpPr>
         <p:spPr>
           <a:xfrm>
-            <a:off x="950976" y="2824988"/>
-            <a:ext cx="10372039" cy="374395"/>
+            <a:off x="950976" y="2039112"/>
+            <a:ext cx="5806440" cy="374395"/>
           </a:xfrm>
           <a:prstGeom prst="rect">
             <a:avLst/>
@@ -7205,21 +7148,21 @@
                 </a:solidFill>
                 <a:latin typeface="Verdana"/>
               </a:rPr>
-              <a:t>Qu'est-ce qu'on voit ?</a:t>
-            </a:r>
-          </a:p>
-        </p:txBody>
-      </p:sp>
-      <p:sp>
-        <p:nvSpPr>
-          <p:cNvPr id="13" name="Rounded Rectangle 12"/>
+              <a:t>Où sommes-nous ?</a:t>
+            </a:r>
+          </a:p>
+        </p:txBody>
+      </p:sp>
+      <p:sp>
+        <p:nvSpPr>
+          <p:cNvPr id="12" name="Rounded Rectangle 11"/>
           <p:cNvSpPr/>
           <p:nvPr/>
         </p:nvSpPr>
         <p:spPr>
           <a:xfrm>
-            <a:off x="566928" y="3427984"/>
-            <a:ext cx="11057839" cy="703579"/>
+            <a:off x="566928" y="2642108"/>
+            <a:ext cx="6492240" cy="703579"/>
           </a:xfrm>
           <a:prstGeom prst="roundRect">
             <a:avLst>
@@ -7258,13 +7201,13 @@
       </p:sp>
       <p:sp>
         <p:nvSpPr>
-          <p:cNvPr id="14" name="Rectangle 13"/>
+          <p:cNvPr id="13" name="Rectangle 12"/>
           <p:cNvSpPr/>
           <p:nvPr/>
         </p:nvSpPr>
         <p:spPr>
           <a:xfrm>
-            <a:off x="566928" y="3537712"/>
+            <a:off x="566928" y="2751836"/>
             <a:ext cx="50292" cy="484123"/>
           </a:xfrm>
           <a:prstGeom prst="rect">
@@ -7300,14 +7243,14 @@
       </p:sp>
       <p:sp>
         <p:nvSpPr>
-          <p:cNvPr id="15" name="TextBox 14"/>
+          <p:cNvPr id="14" name="TextBox 13"/>
           <p:cNvSpPr txBox="1"/>
           <p:nvPr/>
         </p:nvSpPr>
         <p:spPr>
           <a:xfrm>
-            <a:off x="950976" y="3610864"/>
-            <a:ext cx="10372039" cy="374395"/>
+            <a:off x="950976" y="2824988"/>
+            <a:ext cx="5806440" cy="374395"/>
           </a:xfrm>
           <a:prstGeom prst="rect">
             <a:avLst/>
@@ -7332,21 +7275,21 @@
                 </a:solidFill>
                 <a:latin typeface="Verdana"/>
               </a:rPr>
-              <a:t>Qu'est-ce qu'il y a sur les tables ?</a:t>
-            </a:r>
-          </a:p>
-        </p:txBody>
-      </p:sp>
-      <p:sp>
-        <p:nvSpPr>
-          <p:cNvPr id="16" name="Rounded Rectangle 15"/>
+              <a:t>Qu'est-ce qu'on voit ?</a:t>
+            </a:r>
+          </a:p>
+        </p:txBody>
+      </p:sp>
+      <p:sp>
+        <p:nvSpPr>
+          <p:cNvPr id="15" name="Rounded Rectangle 14"/>
           <p:cNvSpPr/>
           <p:nvPr/>
         </p:nvSpPr>
         <p:spPr>
           <a:xfrm>
-            <a:off x="566928" y="4213860"/>
-            <a:ext cx="11057839" cy="703579"/>
+            <a:off x="566928" y="3427984"/>
+            <a:ext cx="6492240" cy="703579"/>
           </a:xfrm>
           <a:prstGeom prst="roundRect">
             <a:avLst>
@@ -7385,13 +7328,13 @@
       </p:sp>
       <p:sp>
         <p:nvSpPr>
-          <p:cNvPr id="17" name="Rectangle 16"/>
+          <p:cNvPr id="16" name="Rectangle 15"/>
           <p:cNvSpPr/>
           <p:nvPr/>
         </p:nvSpPr>
         <p:spPr>
           <a:xfrm>
-            <a:off x="566928" y="4323588"/>
+            <a:off x="566928" y="3537712"/>
             <a:ext cx="50292" cy="484123"/>
           </a:xfrm>
           <a:prstGeom prst="rect">
@@ -7427,14 +7370,141 @@
       </p:sp>
       <p:sp>
         <p:nvSpPr>
-          <p:cNvPr id="18" name="TextBox 17"/>
+          <p:cNvPr id="17" name="TextBox 16"/>
           <p:cNvSpPr txBox="1"/>
           <p:nvPr/>
         </p:nvSpPr>
         <p:spPr>
           <a:xfrm>
+            <a:off x="950976" y="3610864"/>
+            <a:ext cx="5806440" cy="374395"/>
+          </a:xfrm>
+          <a:prstGeom prst="rect">
+            <a:avLst/>
+          </a:prstGeom>
+          <a:noFill/>
+        </p:spPr>
+        <p:txBody>
+          <a:bodyPr wrap="square" lIns="0" rIns="0" tIns="0" bIns="0" anchor="t">
+            <a:spAutoFit/>
+          </a:bodyPr>
+          <a:lstStyle/>
+          <a:p>
+            <a:pPr algn="l">
+              <a:lnSpc>
+                <a:spcPct val="140000"/>
+              </a:lnSpc>
+            </a:pPr>
+            <a:r>
+              <a:rPr sz="1900" b="0" i="0">
+                <a:solidFill>
+                  <a:srgbClr val="3A3D40"/>
+                </a:solidFill>
+                <a:latin typeface="Verdana"/>
+              </a:rPr>
+              <a:t>Qu'est-ce qu'il y a sur les tables ?</a:t>
+            </a:r>
+          </a:p>
+        </p:txBody>
+      </p:sp>
+      <p:sp>
+        <p:nvSpPr>
+          <p:cNvPr id="18" name="Rounded Rectangle 17"/>
+          <p:cNvSpPr/>
+          <p:nvPr/>
+        </p:nvSpPr>
+        <p:spPr>
+          <a:xfrm>
+            <a:off x="566928" y="4213860"/>
+            <a:ext cx="6492240" cy="703579"/>
+          </a:xfrm>
+          <a:prstGeom prst="roundRect">
+            <a:avLst>
+              <a:gd name="adj" fmla="val 20794"/>
+            </a:avLst>
+          </a:prstGeom>
+          <a:solidFill>
+            <a:srgbClr val="FFFFFF"/>
+          </a:solidFill>
+          <a:ln w="12700">
+            <a:solidFill>
+              <a:srgbClr val="EAEAE8"/>
+            </a:solidFill>
+          </a:ln>
+          <a:effectLst/>
+        </p:spPr>
+        <p:style>
+          <a:lnRef idx="1">
+            <a:schemeClr val="accent1"/>
+          </a:lnRef>
+          <a:fillRef idx="3">
+            <a:schemeClr val="accent1"/>
+          </a:fillRef>
+          <a:effectRef idx="2">
+            <a:schemeClr val="accent1"/>
+          </a:effectRef>
+          <a:fontRef idx="minor">
+            <a:schemeClr val="lt1"/>
+          </a:fontRef>
+        </p:style>
+        <p:txBody>
+          <a:bodyPr rtlCol="0" anchor="ctr"/>
+          <a:lstStyle/>
+          <a:p/>
+        </p:txBody>
+      </p:sp>
+      <p:sp>
+        <p:nvSpPr>
+          <p:cNvPr id="19" name="Rectangle 18"/>
+          <p:cNvSpPr/>
+          <p:nvPr/>
+        </p:nvSpPr>
+        <p:spPr>
+          <a:xfrm>
+            <a:off x="566928" y="4323588"/>
+            <a:ext cx="50292" cy="484123"/>
+          </a:xfrm>
+          <a:prstGeom prst="rect">
+            <a:avLst/>
+          </a:prstGeom>
+          <a:solidFill>
+            <a:srgbClr val="1D6B8F"/>
+          </a:solidFill>
+          <a:ln>
+            <a:noFill/>
+          </a:ln>
+          <a:effectLst/>
+        </p:spPr>
+        <p:style>
+          <a:lnRef idx="1">
+            <a:schemeClr val="accent1"/>
+          </a:lnRef>
+          <a:fillRef idx="3">
+            <a:schemeClr val="accent1"/>
+          </a:fillRef>
+          <a:effectRef idx="2">
+            <a:schemeClr val="accent1"/>
+          </a:effectRef>
+          <a:fontRef idx="minor">
+            <a:schemeClr val="lt1"/>
+          </a:fontRef>
+        </p:style>
+        <p:txBody>
+          <a:bodyPr rtlCol="0" anchor="ctr"/>
+          <a:lstStyle/>
+          <a:p/>
+        </p:txBody>
+      </p:sp>
+      <p:sp>
+        <p:nvSpPr>
+          <p:cNvPr id="20" name="TextBox 19"/>
+          <p:cNvSpPr txBox="1"/>
+          <p:nvPr/>
+        </p:nvSpPr>
+        <p:spPr>
+          <a:xfrm>
             <a:off x="950976" y="4396740"/>
-            <a:ext cx="10372039" cy="374395"/>
+            <a:ext cx="5806440" cy="374395"/>
           </a:xfrm>
           <a:prstGeom prst="rect">
             <a:avLst/>

</xml_diff>